<commit_message>
docs(v3.10.0): extrai contrato de harvest para ADR-016, fecha vocabulario de vinculo e leva o sagrado a pauta das liderancas
</commit_message>
<xml_diff>
--- a/docs/apresentacoes/Arquitetura BioCultural v2.pptx
+++ b/docs/apresentacoes/Arquitetura BioCultural v2.pptx
@@ -13638,7 +13638,7 @@
                 <a:cs typeface="Arial"/>
                 <a:sym typeface="Arial"/>
               </a:rPr>
-              <a:t>Quatro perguntas que só vocês podem responder</a:t>
+              <a:t>Cinco perguntas que só vocês podem responder</a:t>
             </a:r>
             <a:endParaRPr b="0" i="0" sz="5400" u="none" cap="none" strike="noStrike">
               <a:solidFill>
@@ -13660,7 +13660,7 @@
         </p:nvSpPr>
         <p:spPr>
           <a:xfrm>
-            <a:off x="1371600" y="3566160"/>
+            <a:off x="1371600" y="2750000"/>
             <a:ext cx="8046720" cy="411480"/>
           </a:xfrm>
           <a:prstGeom prst="rect">
@@ -13726,7 +13726,7 @@
         </p:nvSpPr>
         <p:spPr>
           <a:xfrm>
-            <a:off x="1371600" y="4114800"/>
+            <a:off x="1371600" y="3298640"/>
             <a:ext cx="7534656" cy="1463040"/>
           </a:xfrm>
           <a:prstGeom prst="rect">
@@ -13792,7 +13792,7 @@
         </p:nvSpPr>
         <p:spPr>
           <a:xfrm>
-            <a:off x="9601200" y="3566160"/>
+            <a:off x="9601200" y="2750000"/>
             <a:ext cx="8046720" cy="411480"/>
           </a:xfrm>
           <a:prstGeom prst="rect">
@@ -13858,7 +13858,7 @@
         </p:nvSpPr>
         <p:spPr>
           <a:xfrm>
-            <a:off x="9601200" y="4114800"/>
+            <a:off x="9601200" y="3298640"/>
             <a:ext cx="7534656" cy="1463040"/>
           </a:xfrm>
           <a:prstGeom prst="rect">
@@ -13924,7 +13924,7 @@
         </p:nvSpPr>
         <p:spPr>
           <a:xfrm>
-            <a:off x="1371600" y="5989320"/>
+            <a:off x="1371600" y="5000000"/>
             <a:ext cx="8046720" cy="411480"/>
           </a:xfrm>
           <a:prstGeom prst="rect">
@@ -13990,7 +13990,7 @@
         </p:nvSpPr>
         <p:spPr>
           <a:xfrm>
-            <a:off x="1371600" y="6537960"/>
+            <a:off x="1371600" y="5548640"/>
             <a:ext cx="7534656" cy="1463040"/>
           </a:xfrm>
           <a:prstGeom prst="rect">
@@ -14056,7 +14056,7 @@
         </p:nvSpPr>
         <p:spPr>
           <a:xfrm>
-            <a:off x="9601200" y="5989320"/>
+            <a:off x="9601200" y="5000000"/>
             <a:ext cx="8046720" cy="411480"/>
           </a:xfrm>
           <a:prstGeom prst="rect">
@@ -14122,7 +14122,7 @@
         </p:nvSpPr>
         <p:spPr>
           <a:xfrm>
-            <a:off x="9601200" y="6537960"/>
+            <a:off x="9601200" y="5548640"/>
             <a:ext cx="7534656" cy="1463040"/>
           </a:xfrm>
           <a:prstGeom prst="rect">
@@ -14188,7 +14188,7 @@
         </p:nvSpPr>
         <p:spPr>
           <a:xfrm>
-            <a:off x="1371600" y="8366760"/>
+            <a:off x="1371600" y="9050000"/>
             <a:ext cx="14712696" cy="822960"/>
           </a:xfrm>
           <a:prstGeom prst="rect">
@@ -14233,6 +14233,138 @@
                 <a:sym typeface="Arial"/>
               </a:rPr>
               <a:t>Nenhuma dessas perguntas tem resposta técnica, e nenhuma delas vamos responder sozinhos. Enquanto vocês não responderem, elas ficam registradas como pendências abertas — e nada é publicado.</a:t>
+            </a:r>
+            <a:endParaRPr b="0" i="0" sz="2250" u="none" cap="none" strike="noStrike">
+              <a:solidFill>
+                <a:schemeClr val="dk1"/>
+              </a:solidFill>
+              <a:latin typeface="Calibri"/>
+              <a:ea typeface="Calibri"/>
+              <a:cs typeface="Calibri"/>
+              <a:sym typeface="Calibri"/>
+            </a:endParaRPr>
+          </a:p>
+        </p:txBody>
+      </p:sp>
+      <p:sp>
+        <p:nvSpPr>
+          <p:cNvPr id="190" name="Google Shape;190;p22"/>
+          <p:cNvSpPr/>
+          <p:nvPr/>
+        </p:nvSpPr>
+        <p:spPr>
+          <a:xfrm>
+            <a:off x="1371600" y="7250000"/>
+            <a:ext cx="14712696" cy="411480"/>
+          </a:xfrm>
+          <a:prstGeom prst="rect">
+            <a:avLst/>
+          </a:prstGeom>
+          <a:noFill/>
+          <a:ln>
+            <a:noFill/>
+          </a:ln>
+        </p:spPr>
+        <p:txBody>
+          <a:bodyPr anchorCtr="0" anchor="t" bIns="25400" lIns="25400" spcFirstLastPara="1" rIns="25400" wrap="square" tIns="25400">
+            <a:noAutofit/>
+          </a:bodyPr>
+          <a:lstStyle/>
+          <a:p>
+            <a:pPr indent="0" lvl="0" marL="0" marR="0" rtl="0" algn="l">
+              <a:lnSpc>
+                <a:spcPct val="94203"/>
+              </a:lnSpc>
+              <a:spcBef>
+                <a:spcPts val="0"/>
+              </a:spcBef>
+              <a:spcAft>
+                <a:spcPts val="0"/>
+              </a:spcAft>
+              <a:buClr>
+                <a:srgbClr val="201F1D"/>
+              </a:buClr>
+              <a:buSzPts val="3600"/>
+              <a:buFont typeface="Arial"/>
+              <a:buNone/>
+            </a:pPr>
+            <a:r>
+              <a:rPr b="0" i="0" lang="en-US" sz="3600" u="none" cap="none" strike="noStrike">
+                <a:solidFill>
+                  <a:srgbClr val="201F1D"/>
+                </a:solidFill>
+                <a:latin typeface="Arial"/>
+                <a:ea typeface="Arial"/>
+                <a:cs typeface="Arial"/>
+                <a:sym typeface="Arial"/>
+              </a:rPr>
+              <a:t>O que é sagrado — e o que acontece com ele</a:t>
+            </a:r>
+            <a:endParaRPr b="0" i="0" sz="3600" u="none" cap="none" strike="noStrike">
+              <a:solidFill>
+                <a:schemeClr val="dk1"/>
+              </a:solidFill>
+              <a:latin typeface="Calibri"/>
+              <a:ea typeface="Calibri"/>
+              <a:cs typeface="Calibri"/>
+              <a:sym typeface="Calibri"/>
+            </a:endParaRPr>
+          </a:p>
+        </p:txBody>
+      </p:sp>
+      <p:sp>
+        <p:nvSpPr>
+          <p:cNvPr id="191" name="Google Shape;191;p22"/>
+          <p:cNvSpPr/>
+          <p:nvPr/>
+        </p:nvSpPr>
+        <p:spPr>
+          <a:xfrm>
+            <a:off x="1371600" y="7800000"/>
+            <a:ext cx="14712696" cy="1097280"/>
+          </a:xfrm>
+          <a:prstGeom prst="rect">
+            <a:avLst/>
+          </a:prstGeom>
+          <a:noFill/>
+          <a:ln>
+            <a:noFill/>
+          </a:ln>
+        </p:spPr>
+        <p:txBody>
+          <a:bodyPr anchorCtr="0" anchor="t" bIns="25400" lIns="25400" spcFirstLastPara="1" rIns="25400" wrap="square" tIns="25400">
+            <a:noAutofit/>
+          </a:bodyPr>
+          <a:lstStyle/>
+          <a:p>
+            <a:pPr indent="0" lvl="0" marL="0" marR="0" rtl="0" algn="l">
+              <a:lnSpc>
+                <a:spcPct val="151163"/>
+              </a:lnSpc>
+              <a:spcBef>
+                <a:spcPts val="0"/>
+              </a:spcBef>
+              <a:spcAft>
+                <a:spcPts val="0"/>
+              </a:spcAft>
+              <a:buClr>
+                <a:srgbClr val="201F1D"/>
+              </a:buClr>
+              <a:buSzPts val="2250"/>
+              <a:buFont typeface="Arial"/>
+              <a:buNone/>
+            </a:pPr>
+            <a:r>
+              <a:rPr b="0" i="0" lang="en-US" sz="2250" u="none" cap="none" strike="noStrike">
+                <a:solidFill>
+                  <a:srgbClr val="201F1D"/>
+                </a:solidFill>
+                <a:latin typeface="Arial"/>
+                <a:ea typeface="Arial"/>
+                <a:cs typeface="Arial"/>
+                <a:sym typeface="Arial"/>
+              </a:rPr>
+              <a:t>Quando um saber é sagrado, o registro dele deve sumir por inteiro, ou pode ficar visível que ele existe, sem mostrar o conteúdo? E quem diz que um saber é sagrado?</a:t>
             </a:r>
             <a:endParaRPr b="0" i="0" sz="2250" u="none" cap="none" strike="noStrike">
               <a:solidFill>

</xml_diff>

<commit_message>
style(apresentacao): fundo FAF6EF em todos os slides, tinta 201F1D e secoes em 26221D
</commit_message>
<xml_diff>
--- a/docs/apresentacoes/Arquitetura BioCultural v2.pptx
+++ b/docs/apresentacoes/Arquitetura BioCultural v2.pptx
@@ -5491,12 +5491,12 @@
           <a:spcPts val="0"/>
         </a:spcAft>
         <a:buClr>
-          <a:srgbClr val="000000"/>
+          <a:srgbClr val="201F1D"/>
         </a:buClr>
         <a:buFont typeface="Arial"/>
         <a:defRPr b="0" i="0" spc="0" sz="1400" u="none" cap="none" strike="noStrike">
           <a:solidFill>
-            <a:srgbClr val="000000"/>
+            <a:srgbClr val="201F1D"/>
           </a:solidFill>
           <a:latin typeface="Arial"/>
           <a:ea typeface="Arial"/>
@@ -5515,12 +5515,12 @@
           <a:spcPts val="0"/>
         </a:spcAft>
         <a:buClr>
-          <a:srgbClr val="000000"/>
+          <a:srgbClr val="201F1D"/>
         </a:buClr>
         <a:buFont typeface="Arial"/>
         <a:defRPr b="0" i="0" spc="0" sz="1400" u="none" cap="none" strike="noStrike">
           <a:solidFill>
-            <a:srgbClr val="000000"/>
+            <a:srgbClr val="201F1D"/>
           </a:solidFill>
           <a:latin typeface="Arial"/>
           <a:ea typeface="Arial"/>
@@ -5539,12 +5539,12 @@
           <a:spcPts val="0"/>
         </a:spcAft>
         <a:buClr>
-          <a:srgbClr val="000000"/>
+          <a:srgbClr val="201F1D"/>
         </a:buClr>
         <a:buFont typeface="Arial"/>
         <a:defRPr b="0" i="0" spc="0" sz="1400" u="none" cap="none" strike="noStrike">
           <a:solidFill>
-            <a:srgbClr val="000000"/>
+            <a:srgbClr val="201F1D"/>
           </a:solidFill>
           <a:latin typeface="Arial"/>
           <a:ea typeface="Arial"/>
@@ -5563,12 +5563,12 @@
           <a:spcPts val="0"/>
         </a:spcAft>
         <a:buClr>
-          <a:srgbClr val="000000"/>
+          <a:srgbClr val="201F1D"/>
         </a:buClr>
         <a:buFont typeface="Arial"/>
         <a:defRPr b="0" i="0" spc="0" sz="1400" u="none" cap="none" strike="noStrike">
           <a:solidFill>
-            <a:srgbClr val="000000"/>
+            <a:srgbClr val="201F1D"/>
           </a:solidFill>
           <a:latin typeface="Arial"/>
           <a:ea typeface="Arial"/>
@@ -5587,12 +5587,12 @@
           <a:spcPts val="0"/>
         </a:spcAft>
         <a:buClr>
-          <a:srgbClr val="000000"/>
+          <a:srgbClr val="201F1D"/>
         </a:buClr>
         <a:buFont typeface="Arial"/>
         <a:defRPr b="0" i="0" spc="0" sz="1400" u="none" cap="none" strike="noStrike">
           <a:solidFill>
-            <a:srgbClr val="000000"/>
+            <a:srgbClr val="201F1D"/>
           </a:solidFill>
           <a:latin typeface="Arial"/>
           <a:ea typeface="Arial"/>
@@ -5611,12 +5611,12 @@
           <a:spcPts val="0"/>
         </a:spcAft>
         <a:buClr>
-          <a:srgbClr val="000000"/>
+          <a:srgbClr val="201F1D"/>
         </a:buClr>
         <a:buFont typeface="Arial"/>
         <a:defRPr b="0" i="0" spc="0" sz="1400" u="none" cap="none" strike="noStrike">
           <a:solidFill>
-            <a:srgbClr val="000000"/>
+            <a:srgbClr val="201F1D"/>
           </a:solidFill>
           <a:latin typeface="Arial"/>
           <a:ea typeface="Arial"/>
@@ -5635,12 +5635,12 @@
           <a:spcPts val="0"/>
         </a:spcAft>
         <a:buClr>
-          <a:srgbClr val="000000"/>
+          <a:srgbClr val="201F1D"/>
         </a:buClr>
         <a:buFont typeface="Arial"/>
         <a:defRPr b="0" i="0" spc="0" sz="1400" u="none" cap="none" strike="noStrike">
           <a:solidFill>
-            <a:srgbClr val="000000"/>
+            <a:srgbClr val="201F1D"/>
           </a:solidFill>
           <a:latin typeface="Arial"/>
           <a:ea typeface="Arial"/>
@@ -5659,12 +5659,12 @@
           <a:spcPts val="0"/>
         </a:spcAft>
         <a:buClr>
-          <a:srgbClr val="000000"/>
+          <a:srgbClr val="201F1D"/>
         </a:buClr>
         <a:buFont typeface="Arial"/>
         <a:defRPr b="0" i="0" spc="0" sz="1400" u="none" cap="none" strike="noStrike">
           <a:solidFill>
-            <a:srgbClr val="000000"/>
+            <a:srgbClr val="201F1D"/>
           </a:solidFill>
           <a:latin typeface="Arial"/>
           <a:ea typeface="Arial"/>
@@ -5683,12 +5683,12 @@
           <a:spcPts val="0"/>
         </a:spcAft>
         <a:buClr>
-          <a:srgbClr val="000000"/>
+          <a:srgbClr val="201F1D"/>
         </a:buClr>
         <a:buFont typeface="Arial"/>
         <a:defRPr b="0" i="0" spc="0" sz="1400" u="none" cap="none" strike="noStrike">
           <a:solidFill>
-            <a:srgbClr val="000000"/>
+            <a:srgbClr val="201F1D"/>
           </a:solidFill>
           <a:latin typeface="Arial"/>
           <a:ea typeface="Arial"/>
@@ -5720,12 +5720,12 @@
           <a:spcPts val="0"/>
         </a:spcAft>
         <a:buClr>
-          <a:srgbClr val="000000"/>
+          <a:srgbClr val="201F1D"/>
         </a:buClr>
         <a:buFont typeface="Arial"/>
         <a:defRPr b="0" i="0" spc="0" sz="1400" u="none" cap="none" strike="noStrike">
           <a:solidFill>
-            <a:srgbClr val="000000"/>
+            <a:srgbClr val="201F1D"/>
           </a:solidFill>
           <a:latin typeface="Arial"/>
           <a:ea typeface="Arial"/>
@@ -5744,12 +5744,12 @@
           <a:spcPts val="0"/>
         </a:spcAft>
         <a:buClr>
-          <a:srgbClr val="000000"/>
+          <a:srgbClr val="201F1D"/>
         </a:buClr>
         <a:buFont typeface="Arial"/>
         <a:defRPr b="0" i="0" spc="0" sz="1400" u="none" cap="none" strike="noStrike">
           <a:solidFill>
-            <a:srgbClr val="000000"/>
+            <a:srgbClr val="201F1D"/>
           </a:solidFill>
           <a:latin typeface="Arial"/>
           <a:ea typeface="Arial"/>
@@ -5768,12 +5768,12 @@
           <a:spcPts val="0"/>
         </a:spcAft>
         <a:buClr>
-          <a:srgbClr val="000000"/>
+          <a:srgbClr val="201F1D"/>
         </a:buClr>
         <a:buFont typeface="Arial"/>
         <a:defRPr b="0" i="0" spc="0" sz="1400" u="none" cap="none" strike="noStrike">
           <a:solidFill>
-            <a:srgbClr val="000000"/>
+            <a:srgbClr val="201F1D"/>
           </a:solidFill>
           <a:latin typeface="Arial"/>
           <a:ea typeface="Arial"/>
@@ -5792,12 +5792,12 @@
           <a:spcPts val="0"/>
         </a:spcAft>
         <a:buClr>
-          <a:srgbClr val="000000"/>
+          <a:srgbClr val="201F1D"/>
         </a:buClr>
         <a:buFont typeface="Arial"/>
         <a:defRPr b="0" i="0" spc="0" sz="1400" u="none" cap="none" strike="noStrike">
           <a:solidFill>
-            <a:srgbClr val="000000"/>
+            <a:srgbClr val="201F1D"/>
           </a:solidFill>
           <a:latin typeface="Arial"/>
           <a:ea typeface="Arial"/>
@@ -5816,12 +5816,12 @@
           <a:spcPts val="0"/>
         </a:spcAft>
         <a:buClr>
-          <a:srgbClr val="000000"/>
+          <a:srgbClr val="201F1D"/>
         </a:buClr>
         <a:buFont typeface="Arial"/>
         <a:defRPr b="0" i="0" spc="0" sz="1400" u="none" cap="none" strike="noStrike">
           <a:solidFill>
-            <a:srgbClr val="000000"/>
+            <a:srgbClr val="201F1D"/>
           </a:solidFill>
           <a:latin typeface="Arial"/>
           <a:ea typeface="Arial"/>
@@ -5840,12 +5840,12 @@
           <a:spcPts val="0"/>
         </a:spcAft>
         <a:buClr>
-          <a:srgbClr val="000000"/>
+          <a:srgbClr val="201F1D"/>
         </a:buClr>
         <a:buFont typeface="Arial"/>
         <a:defRPr b="0" i="0" spc="0" sz="1400" u="none" cap="none" strike="noStrike">
           <a:solidFill>
-            <a:srgbClr val="000000"/>
+            <a:srgbClr val="201F1D"/>
           </a:solidFill>
           <a:latin typeface="Arial"/>
           <a:ea typeface="Arial"/>
@@ -5864,12 +5864,12 @@
           <a:spcPts val="0"/>
         </a:spcAft>
         <a:buClr>
-          <a:srgbClr val="000000"/>
+          <a:srgbClr val="201F1D"/>
         </a:buClr>
         <a:buFont typeface="Arial"/>
         <a:defRPr b="0" i="0" spc="0" sz="1400" u="none" cap="none" strike="noStrike">
           <a:solidFill>
-            <a:srgbClr val="000000"/>
+            <a:srgbClr val="201F1D"/>
           </a:solidFill>
           <a:latin typeface="Arial"/>
           <a:ea typeface="Arial"/>
@@ -5888,12 +5888,12 @@
           <a:spcPts val="0"/>
         </a:spcAft>
         <a:buClr>
-          <a:srgbClr val="000000"/>
+          <a:srgbClr val="201F1D"/>
         </a:buClr>
         <a:buFont typeface="Arial"/>
         <a:defRPr b="0" i="0" spc="0" sz="1400" u="none" cap="none" strike="noStrike">
           <a:solidFill>
-            <a:srgbClr val="000000"/>
+            <a:srgbClr val="201F1D"/>
           </a:solidFill>
           <a:latin typeface="Arial"/>
           <a:ea typeface="Arial"/>
@@ -5912,12 +5912,12 @@
           <a:spcPts val="0"/>
         </a:spcAft>
         <a:buClr>
-          <a:srgbClr val="000000"/>
+          <a:srgbClr val="201F1D"/>
         </a:buClr>
         <a:buFont typeface="Arial"/>
         <a:defRPr b="0" i="0" spc="0" sz="1400" u="none" cap="none" strike="noStrike">
           <a:solidFill>
-            <a:srgbClr val="000000"/>
+            <a:srgbClr val="201F1D"/>
           </a:solidFill>
           <a:latin typeface="Arial"/>
           <a:ea typeface="Arial"/>
@@ -5949,12 +5949,12 @@
           <a:spcPts val="0"/>
         </a:spcAft>
         <a:buClr>
-          <a:srgbClr val="000000"/>
+          <a:srgbClr val="201F1D"/>
         </a:buClr>
         <a:buFont typeface="Arial"/>
         <a:defRPr b="0" i="0" spc="0" sz="1400" u="none" cap="none" strike="noStrike">
           <a:solidFill>
-            <a:srgbClr val="000000"/>
+            <a:srgbClr val="201F1D"/>
           </a:solidFill>
           <a:latin typeface="Arial"/>
           <a:ea typeface="Arial"/>
@@ -5973,12 +5973,12 @@
           <a:spcPts val="0"/>
         </a:spcAft>
         <a:buClr>
-          <a:srgbClr val="000000"/>
+          <a:srgbClr val="201F1D"/>
         </a:buClr>
         <a:buFont typeface="Arial"/>
         <a:defRPr b="0" i="0" spc="0" sz="1400" u="none" cap="none" strike="noStrike">
           <a:solidFill>
-            <a:srgbClr val="000000"/>
+            <a:srgbClr val="201F1D"/>
           </a:solidFill>
           <a:latin typeface="Arial"/>
           <a:ea typeface="Arial"/>
@@ -5997,12 +5997,12 @@
           <a:spcPts val="0"/>
         </a:spcAft>
         <a:buClr>
-          <a:srgbClr val="000000"/>
+          <a:srgbClr val="201F1D"/>
         </a:buClr>
         <a:buFont typeface="Arial"/>
         <a:defRPr b="0" i="0" spc="0" sz="1400" u="none" cap="none" strike="noStrike">
           <a:solidFill>
-            <a:srgbClr val="000000"/>
+            <a:srgbClr val="201F1D"/>
           </a:solidFill>
           <a:latin typeface="Arial"/>
           <a:ea typeface="Arial"/>
@@ -6021,12 +6021,12 @@
           <a:spcPts val="0"/>
         </a:spcAft>
         <a:buClr>
-          <a:srgbClr val="000000"/>
+          <a:srgbClr val="201F1D"/>
         </a:buClr>
         <a:buFont typeface="Arial"/>
         <a:defRPr b="0" i="0" spc="0" sz="1400" u="none" cap="none" strike="noStrike">
           <a:solidFill>
-            <a:srgbClr val="000000"/>
+            <a:srgbClr val="201F1D"/>
           </a:solidFill>
           <a:latin typeface="Arial"/>
           <a:ea typeface="Arial"/>
@@ -6045,12 +6045,12 @@
           <a:spcPts val="0"/>
         </a:spcAft>
         <a:buClr>
-          <a:srgbClr val="000000"/>
+          <a:srgbClr val="201F1D"/>
         </a:buClr>
         <a:buFont typeface="Arial"/>
         <a:defRPr b="0" i="0" spc="0" sz="1400" u="none" cap="none" strike="noStrike">
           <a:solidFill>
-            <a:srgbClr val="000000"/>
+            <a:srgbClr val="201F1D"/>
           </a:solidFill>
           <a:latin typeface="Arial"/>
           <a:ea typeface="Arial"/>
@@ -6069,12 +6069,12 @@
           <a:spcPts val="0"/>
         </a:spcAft>
         <a:buClr>
-          <a:srgbClr val="000000"/>
+          <a:srgbClr val="201F1D"/>
         </a:buClr>
         <a:buFont typeface="Arial"/>
         <a:defRPr b="0" i="0" spc="0" sz="1400" u="none" cap="none" strike="noStrike">
           <a:solidFill>
-            <a:srgbClr val="000000"/>
+            <a:srgbClr val="201F1D"/>
           </a:solidFill>
           <a:latin typeface="Arial"/>
           <a:ea typeface="Arial"/>
@@ -6093,12 +6093,12 @@
           <a:spcPts val="0"/>
         </a:spcAft>
         <a:buClr>
-          <a:srgbClr val="000000"/>
+          <a:srgbClr val="201F1D"/>
         </a:buClr>
         <a:buFont typeface="Arial"/>
         <a:defRPr b="0" i="0" spc="0" sz="1400" u="none" cap="none" strike="noStrike">
           <a:solidFill>
-            <a:srgbClr val="000000"/>
+            <a:srgbClr val="201F1D"/>
           </a:solidFill>
           <a:latin typeface="Arial"/>
           <a:ea typeface="Arial"/>
@@ -6117,12 +6117,12 @@
           <a:spcPts val="0"/>
         </a:spcAft>
         <a:buClr>
-          <a:srgbClr val="000000"/>
+          <a:srgbClr val="201F1D"/>
         </a:buClr>
         <a:buFont typeface="Arial"/>
         <a:defRPr b="0" i="0" spc="0" sz="1400" u="none" cap="none" strike="noStrike">
           <a:solidFill>
-            <a:srgbClr val="000000"/>
+            <a:srgbClr val="201F1D"/>
           </a:solidFill>
           <a:latin typeface="Arial"/>
           <a:ea typeface="Arial"/>
@@ -6141,12 +6141,12 @@
           <a:spcPts val="0"/>
         </a:spcAft>
         <a:buClr>
-          <a:srgbClr val="000000"/>
+          <a:srgbClr val="201F1D"/>
         </a:buClr>
         <a:buFont typeface="Arial"/>
         <a:defRPr b="0" i="0" spc="0" sz="1400" u="none" cap="none" strike="noStrike">
           <a:solidFill>
-            <a:srgbClr val="000000"/>
+            <a:srgbClr val="201F1D"/>
           </a:solidFill>
           <a:latin typeface="Arial"/>
           <a:ea typeface="Arial"/>
@@ -6165,7 +6165,7 @@
     <p:bg>
       <p:bgPr>
         <a:solidFill>
-          <a:srgbClr val="F3F2F2"/>
+          <a:srgbClr val="FAF6EF"/>
         </a:solidFill>
       </p:bgPr>
     </p:bg>
@@ -6576,7 +6576,7 @@
     <p:bg>
       <p:bgPr>
         <a:solidFill>
-          <a:srgbClr val="F3F2F2"/>
+          <a:srgbClr val="FAF6EF"/>
         </a:solidFill>
       </p:bgPr>
     </p:bg>
@@ -6954,7 +6954,7 @@
     <p:bg>
       <p:bgPr>
         <a:solidFill>
-          <a:srgbClr val="F3F2F2"/>
+          <a:srgbClr val="FAF6EF"/>
         </a:solidFill>
       </p:bgPr>
     </p:bg>
@@ -7265,7 +7265,7 @@
     <p:bg>
       <p:bgPr>
         <a:solidFill>
-          <a:srgbClr val="F3F2F2"/>
+          <a:srgbClr val="FAF6EF"/>
         </a:solidFill>
       </p:bgPr>
     </p:bg>
@@ -7510,7 +7510,7 @@
     <p:bg>
       <p:bgPr>
         <a:solidFill>
-          <a:srgbClr val="262525"/>
+          <a:srgbClr val="26221D"/>
         </a:solidFill>
       </p:bgPr>
     </p:bg>
@@ -7564,7 +7564,7 @@
                 <a:spcPts val="0"/>
               </a:spcAft>
               <a:buClr>
-                <a:srgbClr val="F3F2F2"/>
+                <a:srgbClr val="FAF6EF"/>
               </a:buClr>
               <a:buSzPts val="5400"/>
               <a:buFont typeface="Arial"/>
@@ -7573,7 +7573,7 @@
             <a:r>
               <a:rPr b="0" i="0" lang="en-US" sz="5400" u="none" cap="none" strike="noStrike">
                 <a:solidFill>
-                  <a:srgbClr val="F3F2F2"/>
+                  <a:srgbClr val="FAF6EF"/>
                 </a:solidFill>
                 <a:latin typeface="Arial"/>
                 <a:ea typeface="Arial"/>
@@ -7608,7 +7608,7 @@
     <p:bg>
       <p:bgPr>
         <a:solidFill>
-          <a:srgbClr val="F3F2F2"/>
+          <a:srgbClr val="FAF6EF"/>
         </a:solidFill>
       </p:bgPr>
     </p:bg>
@@ -9085,7 +9085,7 @@
     <p:bg>
       <p:bgPr>
         <a:solidFill>
-          <a:srgbClr val="262525"/>
+          <a:srgbClr val="26221D"/>
         </a:solidFill>
       </p:bgPr>
     </p:bg>
@@ -9139,7 +9139,7 @@
                 <a:spcPts val="0"/>
               </a:spcAft>
               <a:buClr>
-                <a:srgbClr val="F3F2F2"/>
+                <a:srgbClr val="FAF6EF"/>
               </a:buClr>
               <a:buSzPts val="5400"/>
               <a:buFont typeface="Arial"/>
@@ -9148,7 +9148,7 @@
             <a:r>
               <a:rPr b="0" i="0" lang="en-US" sz="5400" u="none" cap="none" strike="noStrike">
                 <a:solidFill>
-                  <a:srgbClr val="F3F2F2"/>
+                  <a:srgbClr val="FAF6EF"/>
                 </a:solidFill>
                 <a:latin typeface="Arial"/>
                 <a:ea typeface="Arial"/>
@@ -9183,7 +9183,7 @@
     <p:bg>
       <p:bgPr>
         <a:solidFill>
-          <a:srgbClr val="F3F2F2"/>
+          <a:srgbClr val="FAF6EF"/>
         </a:solidFill>
       </p:bgPr>
     </p:bg>
@@ -9282,7 +9282,7 @@
             <a:avLst/>
           </a:prstGeom>
           <a:solidFill>
-            <a:srgbClr val="1F1F1F">
+            <a:srgbClr val="201F1D">
               <a:alpha val="16078"/>
             </a:srgbClr>
           </a:solidFill>
@@ -9459,7 +9459,7 @@
             <a:avLst/>
           </a:prstGeom>
           <a:solidFill>
-            <a:srgbClr val="1F1F1F">
+            <a:srgbClr val="201F1D">
               <a:alpha val="16078"/>
             </a:srgbClr>
           </a:solidFill>
@@ -9636,7 +9636,7 @@
             <a:avLst/>
           </a:prstGeom>
           <a:solidFill>
-            <a:srgbClr val="1F1F1F">
+            <a:srgbClr val="201F1D">
               <a:alpha val="16078"/>
             </a:srgbClr>
           </a:solidFill>
@@ -9813,7 +9813,7 @@
             <a:avLst/>
           </a:prstGeom>
           <a:solidFill>
-            <a:srgbClr val="1F1F1F">
+            <a:srgbClr val="201F1D">
               <a:alpha val="16078"/>
             </a:srgbClr>
           </a:solidFill>
@@ -9990,7 +9990,7 @@
             <a:avLst/>
           </a:prstGeom>
           <a:solidFill>
-            <a:srgbClr val="1F1F1F">
+            <a:srgbClr val="201F1D">
               <a:alpha val="16078"/>
             </a:srgbClr>
           </a:solidFill>
@@ -10167,7 +10167,7 @@
             <a:avLst/>
           </a:prstGeom>
           <a:solidFill>
-            <a:srgbClr val="1F1F1F">
+            <a:srgbClr val="201F1D">
               <a:alpha val="16078"/>
             </a:srgbClr>
           </a:solidFill>
@@ -10238,7 +10238,7 @@
     <p:bg>
       <p:bgPr>
         <a:solidFill>
-          <a:srgbClr val="F3F2F2"/>
+          <a:srgbClr val="FAF6EF"/>
         </a:solidFill>
       </p:bgPr>
     </p:bg>
@@ -10864,7 +10864,7 @@
     <p:bg>
       <p:bgPr>
         <a:solidFill>
-          <a:srgbClr val="F3F2F2"/>
+          <a:srgbClr val="FAF6EF"/>
         </a:solidFill>
       </p:bgPr>
     </p:bg>
@@ -10963,7 +10963,7 @@
             <a:avLst/>
           </a:prstGeom>
           <a:solidFill>
-            <a:srgbClr val="1F1F1F">
+            <a:srgbClr val="201F1D">
               <a:alpha val="16078"/>
             </a:srgbClr>
           </a:solidFill>
@@ -11074,7 +11074,7 @@
             <a:avLst/>
           </a:prstGeom>
           <a:solidFill>
-            <a:srgbClr val="1F1F1F">
+            <a:srgbClr val="201F1D">
               <a:alpha val="16078"/>
             </a:srgbClr>
           </a:solidFill>
@@ -11185,7 +11185,7 @@
             <a:avLst/>
           </a:prstGeom>
           <a:solidFill>
-            <a:srgbClr val="1F1F1F">
+            <a:srgbClr val="201F1D">
               <a:alpha val="16078"/>
             </a:srgbClr>
           </a:solidFill>
@@ -11296,7 +11296,7 @@
             <a:avLst/>
           </a:prstGeom>
           <a:solidFill>
-            <a:srgbClr val="1F1F1F">
+            <a:srgbClr val="201F1D">
               <a:alpha val="16078"/>
             </a:srgbClr>
           </a:solidFill>
@@ -11407,7 +11407,7 @@
             <a:avLst/>
           </a:prstGeom>
           <a:solidFill>
-            <a:srgbClr val="1F1F1F">
+            <a:srgbClr val="201F1D">
               <a:alpha val="16078"/>
             </a:srgbClr>
           </a:solidFill>
@@ -11518,7 +11518,7 @@
             <a:avLst/>
           </a:prstGeom>
           <a:solidFill>
-            <a:srgbClr val="1F1F1F">
+            <a:srgbClr val="201F1D">
               <a:alpha val="16078"/>
             </a:srgbClr>
           </a:solidFill>
@@ -11629,7 +11629,7 @@
             <a:avLst/>
           </a:prstGeom>
           <a:solidFill>
-            <a:srgbClr val="1F1F1F">
+            <a:srgbClr val="201F1D">
               <a:alpha val="16078"/>
             </a:srgbClr>
           </a:solidFill>
@@ -11740,7 +11740,7 @@
             <a:avLst/>
           </a:prstGeom>
           <a:solidFill>
-            <a:srgbClr val="1F1F1F">
+            <a:srgbClr val="201F1D">
               <a:alpha val="16078"/>
             </a:srgbClr>
           </a:solidFill>
@@ -11851,7 +11851,7 @@
             <a:avLst/>
           </a:prstGeom>
           <a:solidFill>
-            <a:srgbClr val="1F1F1F">
+            <a:srgbClr val="201F1D">
               <a:alpha val="16078"/>
             </a:srgbClr>
           </a:solidFill>
@@ -11962,7 +11962,7 @@
             <a:avLst/>
           </a:prstGeom>
           <a:solidFill>
-            <a:srgbClr val="1F1F1F">
+            <a:srgbClr val="201F1D">
               <a:alpha val="16078"/>
             </a:srgbClr>
           </a:solidFill>
@@ -12073,7 +12073,7 @@
             <a:avLst/>
           </a:prstGeom>
           <a:solidFill>
-            <a:srgbClr val="1F1F1F">
+            <a:srgbClr val="201F1D">
               <a:alpha val="16078"/>
             </a:srgbClr>
           </a:solidFill>
@@ -12184,7 +12184,7 @@
             <a:avLst/>
           </a:prstGeom>
           <a:solidFill>
-            <a:srgbClr val="1F1F1F">
+            <a:srgbClr val="201F1D">
               <a:alpha val="16078"/>
             </a:srgbClr>
           </a:solidFill>
@@ -14392,7 +14392,7 @@
     <p:bg>
       <p:bgPr>
         <a:solidFill>
-          <a:srgbClr val="F3F2F2"/>
+          <a:srgbClr val="FAF6EF"/>
         </a:solidFill>
       </p:bgPr>
     </p:bg>
@@ -14754,7 +14754,7 @@
     <p:bg>
       <p:bgPr>
         <a:solidFill>
-          <a:srgbClr val="262525"/>
+          <a:srgbClr val="26221D"/>
         </a:solidFill>
       </p:bgPr>
     </p:bg>
@@ -14808,7 +14808,7 @@
                 <a:spcPts val="0"/>
               </a:spcAft>
               <a:buClr>
-                <a:srgbClr val="F3F2F2"/>
+                <a:srgbClr val="FAF6EF"/>
               </a:buClr>
               <a:buSzPts val="5400"/>
               <a:buFont typeface="Arial"/>
@@ -14817,7 +14817,7 @@
             <a:r>
               <a:rPr b="0" i="0" lang="en-US" sz="5400" u="none" cap="none" strike="noStrike">
                 <a:solidFill>
-                  <a:srgbClr val="F3F2F2"/>
+                  <a:srgbClr val="FAF6EF"/>
                 </a:solidFill>
                 <a:latin typeface="Arial"/>
                 <a:ea typeface="Arial"/>
@@ -14852,7 +14852,7 @@
     <p:bg>
       <p:bgPr>
         <a:solidFill>
-          <a:srgbClr val="F3F2F2"/>
+          <a:srgbClr val="FAF6EF"/>
         </a:solidFill>
       </p:bgPr>
     </p:bg>
@@ -15163,7 +15163,7 @@
     <p:bg>
       <p:bgPr>
         <a:solidFill>
-          <a:srgbClr val="F3F2F2"/>
+          <a:srgbClr val="FAF6EF"/>
         </a:solidFill>
       </p:bgPr>
     </p:bg>
@@ -15552,7 +15552,7 @@
     <p:bg>
       <p:bgPr>
         <a:solidFill>
-          <a:srgbClr val="262525"/>
+          <a:srgbClr val="26221D"/>
         </a:solidFill>
       </p:bgPr>
     </p:bg>
@@ -15606,7 +15606,7 @@
                 <a:spcPts val="0"/>
               </a:spcAft>
               <a:buClr>
-                <a:srgbClr val="F3F2F2"/>
+                <a:srgbClr val="FAF6EF"/>
               </a:buClr>
               <a:buSzPts val="5400"/>
               <a:buFont typeface="Arial"/>
@@ -15615,7 +15615,7 @@
             <a:r>
               <a:rPr b="0" i="0" lang="en-US" sz="5400" u="none" cap="none" strike="noStrike">
                 <a:solidFill>
-                  <a:srgbClr val="F3F2F2"/>
+                  <a:srgbClr val="FAF6EF"/>
                 </a:solidFill>
                 <a:latin typeface="Arial"/>
                 <a:ea typeface="Arial"/>
@@ -15650,7 +15650,7 @@
     <p:bg>
       <p:bgPr>
         <a:solidFill>
-          <a:srgbClr val="F3F2F2"/>
+          <a:srgbClr val="FAF6EF"/>
         </a:solidFill>
       </p:bgPr>
     </p:bg>
@@ -16338,7 +16338,7 @@
     <p:bg>
       <p:bgPr>
         <a:solidFill>
-          <a:srgbClr val="F3F2F2"/>
+          <a:srgbClr val="FAF6EF"/>
         </a:solidFill>
       </p:bgPr>
     </p:bg>
@@ -16747,7 +16747,7 @@
     <p:bg>
       <p:bgPr>
         <a:solidFill>
-          <a:srgbClr val="262525"/>
+          <a:srgbClr val="26221D"/>
         </a:solidFill>
       </p:bgPr>
     </p:bg>
@@ -16801,7 +16801,7 @@
                 <a:spcPts val="0"/>
               </a:spcAft>
               <a:buClr>
-                <a:srgbClr val="F3F2F2"/>
+                <a:srgbClr val="FAF6EF"/>
               </a:buClr>
               <a:buSzPts val="5400"/>
               <a:buFont typeface="Arial"/>
@@ -16810,7 +16810,7 @@
             <a:r>
               <a:rPr b="0" i="0" lang="en-US" sz="5400" u="none" cap="none" strike="noStrike">
                 <a:solidFill>
-                  <a:srgbClr val="F3F2F2"/>
+                  <a:srgbClr val="FAF6EF"/>
                 </a:solidFill>
                 <a:latin typeface="Arial"/>
                 <a:ea typeface="Arial"/>
@@ -16844,10 +16844,10 @@
   <a:themeElements>
     <a:clrScheme name="Office">
       <a:dk1>
-        <a:srgbClr val="000000"/>
+        <a:srgbClr val="201F1D"/>
       </a:dk1>
       <a:lt1>
-        <a:srgbClr val="FFFFFF"/>
+        <a:srgbClr val="FAF6EF"/>
       </a:lt1>
       <a:dk2>
         <a:srgbClr val="44546A"/>
@@ -17123,10 +17123,10 @@
   <a:themeElements>
     <a:clrScheme name="Office">
       <a:dk1>
-        <a:srgbClr val="000000"/>
+        <a:srgbClr val="201F1D"/>
       </a:dk1>
       <a:lt1>
-        <a:srgbClr val="FFFFFF"/>
+        <a:srgbClr val="FAF6EF"/>
       </a:lt1>
       <a:dk2>
         <a:srgbClr val="44546A"/>

</xml_diff>

<commit_message>
fix(slide17): adiciona nó inicial jan/2024 - Base de Dados de Plantas Medicinais
</commit_message>
<xml_diff>
--- a/docs/apresentacoes/Arquitetura BioCultural v2.pptx
+++ b/docs/apresentacoes/Arquitetura BioCultural v2.pptx
@@ -7608,7 +7608,7 @@
         </p:nvSpPr>
         <p:spPr>
           <a:xfrm>
-            <a:off x="1746360" y="5685840"/>
+            <a:off x="3388715" y="5685840"/>
             <a:ext cx="164160" cy="164160"/>
           </a:xfrm>
           <a:prstGeom prst="ellipse">
@@ -7667,8 +7667,8 @@
         </p:nvSpPr>
         <p:spPr>
           <a:xfrm>
-            <a:off x="932760" y="5230440"/>
-            <a:ext cx="1791720" cy="292320"/>
+            <a:off x="2660795" y="5230440"/>
+            <a:ext cx="1620000" cy="292320"/>
           </a:xfrm>
           <a:prstGeom prst="rect">
             <a:avLst/>
@@ -7737,8 +7737,8 @@
         </p:nvSpPr>
         <p:spPr>
           <a:xfrm>
-            <a:off x="941760" y="3017520"/>
-            <a:ext cx="1773720" cy="2121120"/>
+            <a:off x="2660795" y="3017520"/>
+            <a:ext cx="1620000" cy="2121120"/>
           </a:xfrm>
           <a:prstGeom prst="rect">
             <a:avLst/>
@@ -7825,7 +7825,7 @@
         </p:nvSpPr>
         <p:spPr>
           <a:xfrm>
-            <a:off x="3575160" y="5685840"/>
+            <a:off x="5033030" y="5685840"/>
             <a:ext cx="164160" cy="164160"/>
           </a:xfrm>
           <a:prstGeom prst="ellipse">
@@ -7884,8 +7884,8 @@
         </p:nvSpPr>
         <p:spPr>
           <a:xfrm>
-            <a:off x="2761560" y="5989320"/>
-            <a:ext cx="1791720" cy="292320"/>
+            <a:off x="4305110" y="5989320"/>
+            <a:ext cx="1620000" cy="292320"/>
           </a:xfrm>
           <a:prstGeom prst="rect">
             <a:avLst/>
@@ -7954,8 +7954,8 @@
         </p:nvSpPr>
         <p:spPr>
           <a:xfrm>
-            <a:off x="2770560" y="6355080"/>
-            <a:ext cx="1773720" cy="2121120"/>
+            <a:off x="4305110" y="6355080"/>
+            <a:ext cx="1620000" cy="2121120"/>
           </a:xfrm>
           <a:prstGeom prst="rect">
             <a:avLst/>
@@ -8042,7 +8042,7 @@
         </p:nvSpPr>
         <p:spPr>
           <a:xfrm>
-            <a:off x="5403960" y="5685840"/>
+            <a:off x="6677345" y="5685840"/>
             <a:ext cx="164160" cy="164160"/>
           </a:xfrm>
           <a:prstGeom prst="ellipse">
@@ -8101,8 +8101,8 @@
         </p:nvSpPr>
         <p:spPr>
           <a:xfrm>
-            <a:off x="4590360" y="5230440"/>
-            <a:ext cx="1791720" cy="292320"/>
+            <a:off x="5949425" y="5230440"/>
+            <a:ext cx="1620000" cy="292320"/>
           </a:xfrm>
           <a:prstGeom prst="rect">
             <a:avLst/>
@@ -8171,8 +8171,8 @@
         </p:nvSpPr>
         <p:spPr>
           <a:xfrm>
-            <a:off x="4599360" y="3017520"/>
-            <a:ext cx="1773720" cy="2121120"/>
+            <a:off x="5949425" y="3017520"/>
+            <a:ext cx="1620000" cy="2121120"/>
           </a:xfrm>
           <a:prstGeom prst="rect">
             <a:avLst/>
@@ -8259,7 +8259,7 @@
         </p:nvSpPr>
         <p:spPr>
           <a:xfrm>
-            <a:off x="7232760" y="5685840"/>
+            <a:off x="8321660" y="5685840"/>
             <a:ext cx="164160" cy="164160"/>
           </a:xfrm>
           <a:prstGeom prst="ellipse">
@@ -8318,8 +8318,8 @@
         </p:nvSpPr>
         <p:spPr>
           <a:xfrm>
-            <a:off x="6419160" y="5989320"/>
-            <a:ext cx="1791720" cy="292320"/>
+            <a:off x="7593740" y="5989320"/>
+            <a:ext cx="1620000" cy="292320"/>
           </a:xfrm>
           <a:prstGeom prst="rect">
             <a:avLst/>
@@ -8388,8 +8388,8 @@
         </p:nvSpPr>
         <p:spPr>
           <a:xfrm>
-            <a:off x="6428160" y="6355080"/>
-            <a:ext cx="1773720" cy="2121120"/>
+            <a:off x="7593740" y="6355080"/>
+            <a:ext cx="1620000" cy="2121120"/>
           </a:xfrm>
           <a:prstGeom prst="rect">
             <a:avLst/>
@@ -8476,7 +8476,7 @@
         </p:nvSpPr>
         <p:spPr>
           <a:xfrm>
-            <a:off x="9061560" y="5685840"/>
+            <a:off x="9965975" y="5685840"/>
             <a:ext cx="164160" cy="164160"/>
           </a:xfrm>
           <a:prstGeom prst="ellipse">
@@ -8535,8 +8535,8 @@
         </p:nvSpPr>
         <p:spPr>
           <a:xfrm>
-            <a:off x="8247960" y="5230440"/>
-            <a:ext cx="1791720" cy="292320"/>
+            <a:off x="9238055" y="5230440"/>
+            <a:ext cx="1620000" cy="292320"/>
           </a:xfrm>
           <a:prstGeom prst="rect">
             <a:avLst/>
@@ -8605,8 +8605,8 @@
         </p:nvSpPr>
         <p:spPr>
           <a:xfrm>
-            <a:off x="8256960" y="3017520"/>
-            <a:ext cx="1773720" cy="2121120"/>
+            <a:off x="9238055" y="3017520"/>
+            <a:ext cx="1620000" cy="2121120"/>
           </a:xfrm>
           <a:prstGeom prst="rect">
             <a:avLst/>
@@ -8693,7 +8693,7 @@
         </p:nvSpPr>
         <p:spPr>
           <a:xfrm>
-            <a:off x="10890360" y="5685840"/>
+            <a:off x="11610290" y="5685840"/>
             <a:ext cx="164160" cy="164160"/>
           </a:xfrm>
           <a:prstGeom prst="ellipse">
@@ -8752,8 +8752,8 @@
         </p:nvSpPr>
         <p:spPr>
           <a:xfrm>
-            <a:off x="10076760" y="5989320"/>
-            <a:ext cx="1791720" cy="292320"/>
+            <a:off x="10882370" y="5989320"/>
+            <a:ext cx="1620000" cy="292320"/>
           </a:xfrm>
           <a:prstGeom prst="rect">
             <a:avLst/>
@@ -8822,8 +8822,8 @@
         </p:nvSpPr>
         <p:spPr>
           <a:xfrm>
-            <a:off x="10085760" y="6355080"/>
-            <a:ext cx="1773720" cy="2121120"/>
+            <a:off x="10882370" y="6355080"/>
+            <a:ext cx="1620000" cy="2121120"/>
           </a:xfrm>
           <a:prstGeom prst="rect">
             <a:avLst/>
@@ -8910,7 +8910,7 @@
         </p:nvSpPr>
         <p:spPr>
           <a:xfrm>
-            <a:off x="12719160" y="5685840"/>
+            <a:off x="13254605" y="5685840"/>
             <a:ext cx="164160" cy="164160"/>
           </a:xfrm>
           <a:prstGeom prst="ellipse">
@@ -8969,8 +8969,8 @@
         </p:nvSpPr>
         <p:spPr>
           <a:xfrm>
-            <a:off x="11905560" y="5230440"/>
-            <a:ext cx="1791720" cy="292320"/>
+            <a:off x="12526685" y="5230440"/>
+            <a:ext cx="1620000" cy="292320"/>
           </a:xfrm>
           <a:prstGeom prst="rect">
             <a:avLst/>
@@ -9039,8 +9039,8 @@
         </p:nvSpPr>
         <p:spPr>
           <a:xfrm>
-            <a:off x="11914560" y="3017520"/>
-            <a:ext cx="1773720" cy="2121120"/>
+            <a:off x="12526685" y="3017520"/>
+            <a:ext cx="1620000" cy="2121120"/>
           </a:xfrm>
           <a:prstGeom prst="rect">
             <a:avLst/>
@@ -9127,7 +9127,7 @@
         </p:nvSpPr>
         <p:spPr>
           <a:xfrm>
-            <a:off x="14547960" y="5685840"/>
+            <a:off x="14898920" y="5685840"/>
             <a:ext cx="164160" cy="164160"/>
           </a:xfrm>
           <a:prstGeom prst="ellipse">
@@ -9186,8 +9186,8 @@
         </p:nvSpPr>
         <p:spPr>
           <a:xfrm>
-            <a:off x="13734360" y="5989320"/>
-            <a:ext cx="1791720" cy="292320"/>
+            <a:off x="14171000" y="5989320"/>
+            <a:ext cx="1620000" cy="292320"/>
           </a:xfrm>
           <a:prstGeom prst="rect">
             <a:avLst/>
@@ -9256,8 +9256,8 @@
         </p:nvSpPr>
         <p:spPr>
           <a:xfrm>
-            <a:off x="13743360" y="6355080"/>
-            <a:ext cx="1773720" cy="2121120"/>
+            <a:off x="14171000" y="6355080"/>
+            <a:ext cx="1620000" cy="2121120"/>
           </a:xfrm>
           <a:prstGeom prst="rect">
             <a:avLst/>
@@ -9344,7 +9344,7 @@
         </p:nvSpPr>
         <p:spPr>
           <a:xfrm>
-            <a:off x="16376760" y="5685840"/>
+            <a:off x="16543235" y="5685840"/>
             <a:ext cx="164160" cy="164160"/>
           </a:xfrm>
           <a:prstGeom prst="ellipse">
@@ -9403,8 +9403,8 @@
         </p:nvSpPr>
         <p:spPr>
           <a:xfrm>
-            <a:off x="15563160" y="5230440"/>
-            <a:ext cx="1791720" cy="292320"/>
+            <a:off x="15815315" y="5230440"/>
+            <a:ext cx="1620000" cy="292320"/>
           </a:xfrm>
           <a:prstGeom prst="rect">
             <a:avLst/>
@@ -9473,8 +9473,8 @@
         </p:nvSpPr>
         <p:spPr>
           <a:xfrm>
-            <a:off x="15572160" y="3017520"/>
-            <a:ext cx="1773720" cy="2121120"/>
+            <a:off x="15815315" y="3017520"/>
+            <a:ext cx="1620000" cy="2121120"/>
           </a:xfrm>
           <a:prstGeom prst="rect">
             <a:avLst/>
@@ -9541,6 +9541,211 @@
                 <a:ea typeface="Arial"/>
               </a:rPr>
               <a:t>o Relato, o consentimento como processo, as gravações e as oficinas</a:t>
+            </a:r>
+            <a:endParaRPr lang="pt-BR" sz="1250" b="0" u="none" strike="noStrike">
+              <a:solidFill>
+                <a:srgbClr val="000000"/>
+              </a:solidFill>
+              <a:effectLst/>
+              <a:uFillTx/>
+              <a:latin typeface="Arial"/>
+            </a:endParaRPr>
+          </a:p>
+        </p:txBody>
+      </p:sp>
+      <p:sp>
+        <p:nvSpPr>
+          <p:cNvPr id="200" name="Oval 200"/>
+          <p:cNvSpPr/>
+          <p:nvPr/>
+        </p:nvSpPr>
+        <p:spPr>
+          <a:xfrm>
+            <a:off x="1744400" y="5685840"/>
+            <a:ext cx="164160" cy="164160"/>
+          </a:xfrm>
+          <a:prstGeom prst="ellipse">
+            <a:avLst/>
+          </a:prstGeom>
+          <a:solidFill>
+            <a:srgbClr val="B4542F"/>
+          </a:solidFill>
+          <a:ln w="19050">
+            <a:solidFill>
+              <a:srgbClr val="FAF6EF"/>
+            </a:solidFill>
+            <a:round/>
+          </a:ln>
+          <a:effectLst>
+            <a:outerShdw blurRad="39960" dir="5400000" dist="23040" rotWithShape="0">
+              <a:srgbClr val="000000">
+                <a:alpha val="35000"/>
+              </a:srgbClr>
+            </a:outerShdw>
+          </a:effectLst>
+        </p:spPr>
+        <p:style>
+          <a:lnRef idx="1">
+            <a:schemeClr val="accent1"/>
+          </a:lnRef>
+          <a:fillRef idx="3">
+            <a:schemeClr val="accent1"/>
+          </a:fillRef>
+          <a:effectRef idx="2">
+            <a:schemeClr val="accent1"/>
+          </a:effectRef>
+          <a:fontRef idx="minor"/>
+        </p:style>
+        <p:txBody>
+          <a:bodyPr lIns="90000" tIns="45000" rIns="90000" bIns="45000" anchor="ctr">
+            <a:noAutofit/>
+          </a:bodyPr>
+          <a:p>
+            <a:endParaRPr lang="pt-BR" sz="1400" b="0" u="none" strike="noStrike">
+              <a:solidFill>
+                <a:schemeClr val="lt1"/>
+              </a:solidFill>
+              <a:effectLst/>
+              <a:uFillTx/>
+              <a:latin typeface="Arial"/>
+            </a:endParaRPr>
+          </a:p>
+        </p:txBody>
+      </p:sp>
+      <p:sp>
+        <p:nvSpPr>
+          <p:cNvPr id="201" name="TextBox 201"/>
+          <p:cNvSpPr/>
+          <p:nvPr/>
+        </p:nvSpPr>
+        <p:spPr>
+          <a:xfrm>
+            <a:off x="1016480" y="5989320"/>
+            <a:ext cx="1620000" cy="292320"/>
+          </a:xfrm>
+          <a:prstGeom prst="rect">
+            <a:avLst/>
+          </a:prstGeom>
+          <a:noFill/>
+          <a:ln w="0">
+            <a:noFill/>
+          </a:ln>
+        </p:spPr>
+        <p:style>
+          <a:lnRef idx="0"/>
+          <a:fillRef idx="0"/>
+          <a:effectRef idx="0"/>
+          <a:fontRef idx="minor"/>
+        </p:style>
+        <p:txBody>
+          <a:bodyPr lIns="0" tIns="0" rIns="0" bIns="0" anchor="t">
+            <a:spAutoFit/>
+          </a:bodyPr>
+          <a:p>
+            <a:pPr algn="ctr">
+              <a:lnSpc>
+                <a:spcPct val="100000"/>
+              </a:lnSpc>
+            </a:pPr>
+            <a:r>
+              <a:rPr lang="pt-BR" sz="1350" b="1" u="none" strike="noStrike">
+                <a:solidFill>
+                  <a:srgbClr val="201F1D"/>
+                </a:solidFill>
+                <a:effectLst/>
+                <a:uFillTx/>
+                <a:latin typeface="Arial"/>
+                <a:ea typeface="Arial"/>
+              </a:rPr>
+              <a:t>jan/2024 · v0.1</a:t>
+            </a:r>
+            <a:endParaRPr lang="pt-BR" sz="1350" b="0" u="none" strike="noStrike">
+              <a:solidFill>
+                <a:srgbClr val="000000"/>
+              </a:solidFill>
+              <a:effectLst/>
+              <a:uFillTx/>
+              <a:latin typeface="Arial"/>
+            </a:endParaRPr>
+          </a:p>
+        </p:txBody>
+      </p:sp>
+      <p:sp>
+        <p:nvSpPr>
+          <p:cNvPr id="202" name="TextBox 202"/>
+          <p:cNvSpPr/>
+          <p:nvPr/>
+        </p:nvSpPr>
+        <p:spPr>
+          <a:xfrm>
+            <a:off x="1016480" y="6355080"/>
+            <a:ext cx="1620000" cy="2121120"/>
+          </a:xfrm>
+          <a:prstGeom prst="rect">
+            <a:avLst/>
+          </a:prstGeom>
+          <a:noFill/>
+          <a:ln w="0">
+            <a:noFill/>
+          </a:ln>
+        </p:spPr>
+        <p:style>
+          <a:lnRef idx="0"/>
+          <a:fillRef idx="0"/>
+          <a:effectRef idx="0"/>
+          <a:fontRef idx="minor"/>
+        </p:style>
+        <p:txBody>
+          <a:bodyPr lIns="0" tIns="0" rIns="0" bIns="0" anchor="t">
+            <a:spAutoFit/>
+          </a:bodyPr>
+          <a:p>
+            <a:pPr algn="ctr">
+              <a:lnSpc>
+                <a:spcPct val="100000"/>
+              </a:lnSpc>
+            </a:pPr>
+            <a:r>
+              <a:rPr lang="pt-BR" sz="1600" b="1" u="none" strike="noStrike">
+                <a:solidFill>
+                  <a:srgbClr val="B4542F"/>
+                </a:solidFill>
+                <a:effectLst/>
+                <a:uFillTx/>
+                <a:latin typeface="Arial"/>
+                <a:ea typeface="Arial"/>
+              </a:rPr>
+              <a:t>Base de Dados de Plantas Medicinais</a:t>
+            </a:r>
+            <a:endParaRPr lang="pt-BR" sz="1600" b="0" u="none" strike="noStrike">
+              <a:solidFill>
+                <a:srgbClr val="000000"/>
+              </a:solidFill>
+              <a:effectLst/>
+              <a:uFillTx/>
+              <a:latin typeface="Arial"/>
+            </a:endParaRPr>
+          </a:p>
+          <a:p>
+            <a:pPr algn="ctr">
+              <a:lnSpc>
+                <a:spcPct val="100000"/>
+              </a:lnSpc>
+              <a:spcBef>
+                <a:spcPts val="400"/>
+              </a:spcBef>
+            </a:pPr>
+            <a:r>
+              <a:rPr lang="pt-BR" sz="1250" b="0" u="none" strike="noStrike">
+                <a:solidFill>
+                  <a:srgbClr val="5C554C"/>
+                </a:solidFill>
+                <a:effectLst/>
+                <a:uFillTx/>
+                <a:latin typeface="Arial"/>
+                <a:ea typeface="Arial"/>
+              </a:rPr>
+              <a:t>Dra. Viviane Fonseca · gitserver.jbrj.gov.br/edalcin/bdmedicinais</a:t>
             </a:r>
             <a:endParaRPr lang="pt-BR" sz="1250" b="0" u="none" strike="noStrike">
               <a:solidFill>

</xml_diff>